<commit_message>
Short slides: update from the latest project report (greedy success, warm-start and pre-training efficiency)
Co-Authored-By: Claude Opus 5.5 <noreply@anthropic.com>
Claude-Session: https://claude.ai/code/session_01RobwG4fG7s83Eyb7XAeMFj
</commit_message>
<xml_diff>
--- a/docs/project_slides_short.pptx
+++ b/docs/project_slides_short.pptx
@@ -126,25 +126,25 @@
   <p:extLst>
     <p:ext uri="{521415D9-36F7-43E2-AB2F-B90AF26B5E84}">
       <p14:sectionLst xmlns:p14="http://schemas.microsoft.com/office/powerpoint/2010/main">
-        <p14:section name="概述" id="{1e192201-ae95-0252-90bf-e6e381bfcdbd}">
+        <p14:section name="概述" id="{7a289628-966f-3744-8ae2-f21bf9b9f3ea}">
           <p14:sldIdLst>
             <p14:sldId id="257"/>
           </p14:sldIdLst>
         </p14:section>
-        <p14:section name="方法" id="{1c2d9176-19c1-5fd2-e677-8a563864f04c}">
+        <p14:section name="方法" id="{d6d1394d-75e1-cf9d-8cd4-29eae1b25981}">
           <p14:sldIdLst>
             <p14:sldId id="258"/>
             <p14:sldId id="259"/>
             <p14:sldId id="260"/>
           </p14:sldIdLst>
         </p14:section>
-        <p14:section name="實驗設置" id="{b7241344-6218-41e3-39d8-cee992e1d0cb}">
+        <p14:section name="實驗設置" id="{6ef84977-32d6-7fee-0ddb-23f760a81b18}">
           <p14:sldIdLst>
             <p14:sldId id="261"/>
             <p14:sldId id="262"/>
           </p14:sldIdLst>
         </p14:section>
-        <p14:section name="實驗結果" id="{1e86b7c9-ce1f-215c-ff17-d04670a2d852}">
+        <p14:section name="實驗結果" id="{6dbffff4-7f8c-3560-6698-701b72ea5aae}">
           <p14:sldIdLst>
             <p14:sldId id="263"/>
             <p14:sldId id="264"/>
@@ -156,12 +156,12 @@
             <p14:sldId id="270"/>
           </p14:sldIdLst>
         </p14:section>
-        <p14:section name="結論" id="{59c5ca0a-07a3-9569-31b3-7cbf81874bee}">
+        <p14:section name="結論" id="{c98522cb-5184-852f-a801-92406437bc0b}">
           <p14:sldIdLst>
             <p14:sldId id="271"/>
           </p14:sldIdLst>
         </p14:section>
-        <p14:section name="附錄" id="{17530d26-9675-64e7-7a91-92e048a502c3}">
+        <p14:section name="附錄" id="{06463b36-c538-6326-a4c8-cefe664e52b9}">
           <p14:sldIdLst>
             <p14:sldId id="272"/>
             <p14:sldId id="273"/>
@@ -1120,7 +1120,7 @@
                 <c:formatCode>General</c:formatCode>
                 <c:ptCount val="2"/>
                 <c:pt idx="0">
-                  <c:v>0.601</c:v>
+                  <c:v>0.6</c:v>
                 </c:pt>
                 <c:pt idx="1">
                   <c:v>0.396</c:v>
@@ -5129,7 +5129,7 @@
                   <a:schemeClr val="tx1"/>
                 </a:solidFill>
               </a:rPr>
-              <a:t>L3-goal（PUCT16）：增益主要來自成功率</a:t>
+              <a:t>L3-goal（PUCT16）：增益幾乎全部來自成功率</a:t>
             </a:r>
             <a:endParaRPr lang="en-US" sz="3200" dirty="0"/>
           </a:p>
@@ -5515,7 +5515,7 @@
                             <a:schemeClr val="tx2"/>
                           </a:solidFill>
                         </a:rPr>
-                        <a:t>—</a:t>
+                        <a:t>27.4*</a:t>
                       </a:r>
                       <a:endParaRPr lang="en-US" sz="1300" dirty="0"/>
                     </a:p>
@@ -5555,7 +5555,7 @@
                             <a:schemeClr val="tx2"/>
                           </a:solidFill>
                         </a:rPr>
-                        <a:t>—</a:t>
+                        <a:t>10.2</a:t>
                       </a:r>
                       <a:endParaRPr lang="en-US" sz="1300" dirty="0"/>
                     </a:p>
@@ -5717,7 +5717,7 @@
                             <a:schemeClr val="tx1"/>
                           </a:solidFill>
                         </a:rPr>
-                        <a:t>—</a:t>
+                        <a:t>28.7*</a:t>
                       </a:r>
                       <a:endParaRPr lang="en-US" sz="1300" dirty="0"/>
                     </a:p>
@@ -5757,7 +5757,7 @@
                             <a:schemeClr val="tx1"/>
                           </a:solidFill>
                         </a:rPr>
-                        <a:t>—</a:t>
+                        <a:t>11.7</a:t>
                       </a:r>
                       <a:endParaRPr lang="en-US" sz="1300" dirty="0"/>
                     </a:p>
@@ -5879,7 +5879,7 @@
                             <a:schemeClr val="tx1"/>
                           </a:solidFill>
                         </a:rPr>
-                        <a:t>—</a:t>
+                        <a:t>0.54</a:t>
                       </a:r>
                       <a:endParaRPr lang="en-US" sz="1300" dirty="0"/>
                     </a:p>
@@ -5919,7 +5919,7 @@
                             <a:schemeClr val="tx1"/>
                           </a:solidFill>
                         </a:rPr>
-                        <a:t>—</a:t>
+                        <a:t>18.4</a:t>
                       </a:r>
                       <a:endParaRPr lang="en-US" sz="1300" dirty="0"/>
                     </a:p>
@@ -5959,7 +5959,7 @@
                             <a:schemeClr val="tx1"/>
                           </a:solidFill>
                         </a:rPr>
-                        <a:t>—</a:t>
+                        <a:t>8.6</a:t>
                       </a:r>
                       <a:endParaRPr lang="en-US" sz="1300" dirty="0"/>
                     </a:p>
@@ -6840,7 +6840,7 @@
                   <a:schemeClr val="tx1"/>
                 </a:solidFill>
               </a:rPr>
-              <a:t>0.59 → 0.89</a:t>
+              <a:t>warm start 0.54 → self-play 0.89；teacher-only 僅 0.59</a:t>
             </a:r>
             <a:endParaRPr lang="en-US" sz="1400" dirty="0"/>
           </a:p>
@@ -6866,7 +6866,33 @@
                   <a:schemeClr val="tx1"/>
                 </a:solidFill>
               </a:rPr>
-              <a:t>10.2 → 8.6，接近任務最短 8 步</a:t>
+              <a:t>warm start 已為 8.6（任務最短 8 步），self-play 後不變</a:t>
+            </a:r>
+            <a:endParaRPr lang="en-US" sz="1400" dirty="0"/>
+          </a:p>
+          <a:p>
+            <a:pPr marL="203200" indent="-203200">
+              <a:spcAft>
+                <a:spcPts val="1000"/>
+              </a:spcAft>
+              <a:buSzPct val="100000"/>
+              <a:buChar char="•"/>
+            </a:pPr>
+            <a:r>
+              <a:rPr lang="en-US" sz="1400" b="1" dirty="0">
+                <a:solidFill>
+                  <a:schemeClr val="tx1"/>
+                </a:solidFill>
+              </a:rPr>
+              <a:t>Teacher-only 10.2 步：</a:t>
+            </a:r>
+            <a:r>
+              <a:rPr lang="en-US" sz="1400" dirty="0">
+                <a:solidFill>
+                  <a:schemeClr val="tx1"/>
+                </a:solidFill>
+              </a:rPr>
+              <a:t>自身退步（8.7 → 10.2），非 self-play 縮短解法</a:t>
             </a:r>
             <a:endParaRPr lang="en-US" sz="1400" dirty="0"/>
           </a:p>
@@ -6892,7 +6918,7 @@
                   <a:schemeClr val="tx1"/>
                 </a:solidFill>
               </a:rPr>
-              <a:t>18.3 → 11.0，主因為失敗局減少</a:t>
+              <a:t>下降主因為失敗局減少</a:t>
             </a:r>
             <a:endParaRPr lang="en-US" sz="1400" dirty="0"/>
           </a:p>
@@ -6910,7 +6936,7 @@
                   <a:schemeClr val="tx1"/>
                 </a:solidFill>
               </a:rPr>
-              <a:t>進階變體：</a:t>
+              <a:t>訓練前：</a:t>
             </a:r>
             <a:r>
               <a:rPr lang="en-US" sz="1400" dirty="0">
@@ -6918,33 +6944,7 @@
                   <a:schemeClr val="tx1"/>
                 </a:solidFill>
               </a:rPr>
-              <a:t>成功率與步數皆無優勢</a:t>
-            </a:r>
-            <a:endParaRPr lang="en-US" sz="1400" dirty="0"/>
-          </a:p>
-          <a:p>
-            <a:pPr marL="203200" indent="-203200">
-              <a:spcAft>
-                <a:spcPts val="1000"/>
-              </a:spcAft>
-              <a:buSzPct val="100000"/>
-              <a:buChar char="•"/>
-            </a:pPr>
-            <a:r>
-              <a:rPr lang="en-US" sz="1400" b="1" dirty="0">
-                <a:solidFill>
-                  <a:schemeClr val="tx1"/>
-                </a:solidFill>
-              </a:rPr>
-              <a:t>剩餘空間：</a:t>
-            </a:r>
-            <a:r>
-              <a:rPr lang="en-US" sz="1400" dirty="0">
-                <a:solidFill>
-                  <a:schemeClr val="tx1"/>
-                </a:solidFill>
-              </a:rPr>
-              <a:t>約 11% 未解出，主要在成功率而非效率</a:t>
+              <a:t>解出的局需 10–12 步，效率差</a:t>
             </a:r>
             <a:endParaRPr lang="en-US" sz="1400" dirty="0"/>
           </a:p>
@@ -6980,7 +6980,7 @@
                   <a:schemeClr val="tx2"/>
                 </a:solidFill>
               </a:rPr>
-              <a:t>100 局測試集；± 為 3 個 seed 標準差。平均步數含失敗局（以上限 30 步計）；成功局平均步數僅計解出的局。— 為報告未記錄。</a:t>
+              <a:t>100 局測試集；± 為 3 個 seed 標準差。平均步數含失敗局（以上限 30 步計）；成功局平均步數僅計解出的局。* 依成功率與成功局步數換算。</a:t>
             </a:r>
             <a:endParaRPr lang="en-US" sz="1100" dirty="0"/>
           </a:p>
@@ -7016,7 +7016,7 @@
                   <a:schemeClr val="tx2"/>
                 </a:solidFill>
               </a:rPr>
-              <a:t>Warm start 為全部實驗平均；隨機 rollout 與原始 Laya 不經訓練，與 seed 無關。</a:t>
+              <a:t>Warm start 為 4 組設定（12 個實驗）平均；隨機 rollout 與原始 Laya 不經訓練，與 seed 無關。</a:t>
             </a:r>
             <a:endParaRPr lang="en-US" sz="1100" dirty="0"/>
           </a:p>
@@ -7160,7 +7160,7 @@
                   <a:schemeClr val="tx1"/>
                 </a:solidFill>
               </a:rPr>
-              <a:t>L3-goal（Greedy）：網路本身的提升有限</a:t>
+              <a:t>L3-goal（Greedy）：policy 提升相近，差別在搜尋</a:t>
             </a:r>
             <a:endParaRPr lang="en-US" sz="3200" dirty="0"/>
           </a:p>
@@ -7546,7 +7546,7 @@
                             <a:schemeClr val="tx1"/>
                           </a:solidFill>
                         </a:rPr>
-                        <a:t>—</a:t>
+                        <a:t>29.1*</a:t>
                       </a:r>
                       <a:endParaRPr lang="en-US" sz="1300" dirty="0"/>
                     </a:p>
@@ -7586,7 +7586,7 @@
                             <a:schemeClr val="tx1"/>
                           </a:solidFill>
                         </a:rPr>
-                        <a:t>—</a:t>
+                        <a:t>7.0</a:t>
                       </a:r>
                       <a:endParaRPr lang="en-US" sz="1300" dirty="0"/>
                     </a:p>
@@ -7708,7 +7708,7 @@
                             <a:schemeClr val="tx1"/>
                           </a:solidFill>
                         </a:rPr>
-                        <a:t>—</a:t>
+                        <a:t>0.42</a:t>
                       </a:r>
                       <a:endParaRPr lang="en-US" sz="1300" dirty="0"/>
                     </a:p>
@@ -7910,7 +7910,7 @@
                             <a:schemeClr val="tx1"/>
                           </a:solidFill>
                         </a:rPr>
-                        <a:t>—</a:t>
+                        <a:t>0.53</a:t>
                       </a:r>
                       <a:endParaRPr lang="en-US" sz="1300" dirty="0"/>
                     </a:p>
@@ -8112,7 +8112,7 @@
                             <a:schemeClr val="accent1"/>
                           </a:solidFill>
                         </a:rPr>
-                        <a:t>—</a:t>
+                        <a:t>0.61</a:t>
                       </a:r>
                       <a:endParaRPr lang="en-US" sz="1300" dirty="0"/>
                     </a:p>
@@ -8314,7 +8314,7 @@
                             <a:schemeClr val="tx2"/>
                           </a:solidFill>
                         </a:rPr>
-                        <a:t>—</a:t>
+                        <a:t>0.63</a:t>
                       </a:r>
                       <a:endParaRPr lang="en-US" sz="1300" dirty="0"/>
                     </a:p>
@@ -8516,7 +8516,7 @@
                             <a:schemeClr val="tx2"/>
                           </a:solidFill>
                         </a:rPr>
-                        <a:t>—</a:t>
+                        <a:t>0.66</a:t>
                       </a:r>
                       <a:endParaRPr lang="en-US" sz="1300" dirty="0"/>
                     </a:p>
@@ -8636,7 +8636,7 @@
         <p:spPr>
           <a:xfrm>
             <a:off x="8229600" y="1691640"/>
-            <a:ext cx="3273552" cy="365760"/>
+            <a:ext cx="3273552" cy="548640"/>
           </a:xfrm>
           <a:prstGeom prst="rect">
             <a:avLst/>
@@ -8657,7 +8657,7 @@
                   <a:schemeClr val="tx2"/>
                 </a:solidFill>
               </a:rPr>
-              <a:t>Self-play − Teacher-only</a:t>
+              <a:t>搜尋多解出的局（PUCT16 − Greedy 成功率）</a:t>
             </a:r>
             <a:endParaRPr lang="en-US" sz="1300" dirty="0"/>
           </a:p>
@@ -8665,50 +8665,14 @@
       </p:sp>
       <p:sp>
         <p:nvSpPr>
-          <p:cNvPr id="6" name="stat: Greedy"/>
+          <p:cNvPr id="6" name="Text 3"/>
           <p:cNvSpPr txBox="1"/>
           <p:nvPr/>
         </p:nvSpPr>
         <p:spPr>
           <a:xfrm>
-            <a:off x="8229600" y="2011680"/>
-            <a:ext cx="1554480" cy="822960"/>
-          </a:xfrm>
-          <a:prstGeom prst="rect">
-            <a:avLst/>
-          </a:prstGeom>
-          <a:noFill/>
-          <a:ln/>
-        </p:spPr>
-        <p:txBody>
-          <a:bodyPr wrap="square" lIns="0" tIns="0" rIns="0" bIns="0" rtlCol="0" anchor="b"/>
-          <a:lstStyle/>
-          <a:p>
-            <a:pPr indent="0" marL="0">
-              <a:buNone/>
-            </a:pPr>
-            <a:r>
-              <a:rPr lang="en-US" sz="3600" b="1" dirty="0">
-                <a:solidFill>
-                  <a:schemeClr val="tx1"/>
-                </a:solidFill>
-              </a:rPr>
-              <a:t>+0.06</a:t>
-            </a:r>
-            <a:endParaRPr lang="en-US" sz="3600" dirty="0"/>
-          </a:p>
-        </p:txBody>
-      </p:sp>
-      <p:sp>
-        <p:nvSpPr>
-          <p:cNvPr id="7" name="stat label: Greedy"/>
-          <p:cNvSpPr txBox="1"/>
-          <p:nvPr/>
-        </p:nvSpPr>
-        <p:spPr>
-          <a:xfrm>
-            <a:off x="8229600" y="2907792"/>
-            <a:ext cx="1554480" cy="640080"/>
+            <a:off x="8229600" y="2240280"/>
+            <a:ext cx="3273552" cy="274320"/>
           </a:xfrm>
           <a:prstGeom prst="rect">
             <a:avLst/>
@@ -8724,63 +8688,27 @@
               <a:buNone/>
             </a:pPr>
             <a:r>
-              <a:rPr lang="en-US" sz="1300" dirty="0">
+              <a:rPr lang="en-US" sz="1100" dirty="0">
                 <a:solidFill>
                   <a:schemeClr val="tx2"/>
                 </a:solidFill>
               </a:rPr>
-              <a:t>Greedy</a:t>
+              <a:t>warm start → 最終</a:t>
             </a:r>
-            <a:endParaRPr lang="en-US" sz="1300" dirty="0"/>
+            <a:endParaRPr lang="en-US" sz="1100" dirty="0"/>
           </a:p>
         </p:txBody>
       </p:sp>
       <p:sp>
         <p:nvSpPr>
-          <p:cNvPr id="8" name="stat: PUCT16"/>
+          <p:cNvPr id="7" name="Text 4"/>
           <p:cNvSpPr txBox="1"/>
           <p:nvPr/>
         </p:nvSpPr>
         <p:spPr>
           <a:xfrm>
-            <a:off x="9921240" y="2011680"/>
-            <a:ext cx="1554480" cy="822960"/>
-          </a:xfrm>
-          <a:prstGeom prst="rect">
-            <a:avLst/>
-          </a:prstGeom>
-          <a:noFill/>
-          <a:ln/>
-        </p:spPr>
-        <p:txBody>
-          <a:bodyPr wrap="square" lIns="0" tIns="0" rIns="0" bIns="0" rtlCol="0" anchor="b"/>
-          <a:lstStyle/>
-          <a:p>
-            <a:pPr indent="0" marL="0">
-              <a:buNone/>
-            </a:pPr>
-            <a:r>
-              <a:rPr lang="en-US" sz="3600" b="1" dirty="0">
-                <a:solidFill>
-                  <a:schemeClr val="accent1"/>
-                </a:solidFill>
-              </a:rPr>
-              <a:t>+0.23</a:t>
-            </a:r>
-            <a:endParaRPr lang="en-US" sz="3600" dirty="0"/>
-          </a:p>
-        </p:txBody>
-      </p:sp>
-      <p:sp>
-        <p:nvSpPr>
-          <p:cNvPr id="9" name="stat label: PUCT16"/>
-          <p:cNvSpPr txBox="1"/>
-          <p:nvPr/>
-        </p:nvSpPr>
-        <p:spPr>
-          <a:xfrm>
-            <a:off x="9921240" y="2907792"/>
-            <a:ext cx="1554480" cy="640080"/>
+            <a:off x="8229600" y="2651760"/>
+            <a:ext cx="3273552" cy="320040"/>
           </a:xfrm>
           <a:prstGeom prst="rect">
             <a:avLst/>
@@ -8796,27 +8724,27 @@
               <a:buNone/>
             </a:pPr>
             <a:r>
-              <a:rPr lang="en-US" sz="1300" dirty="0">
+              <a:rPr lang="en-US" sz="1500" b="1" dirty="0">
                 <a:solidFill>
                   <a:schemeClr val="tx2"/>
                 </a:solidFill>
               </a:rPr>
-              <a:t>PUCT16</a:t>
+              <a:t>Teacher-only</a:t>
             </a:r>
-            <a:endParaRPr lang="en-US" sz="1300" dirty="0"/>
+            <a:endParaRPr lang="en-US" sz="1500" dirty="0"/>
           </a:p>
         </p:txBody>
       </p:sp>
       <p:sp>
         <p:nvSpPr>
-          <p:cNvPr id="10" name="Text 7"/>
+          <p:cNvPr id="8" name="Text 5"/>
           <p:cNvSpPr txBox="1"/>
           <p:nvPr/>
         </p:nvSpPr>
         <p:spPr>
           <a:xfrm>
-            <a:off x="8229600" y="3794760"/>
-            <a:ext cx="3273552" cy="1097280"/>
+            <a:off x="8229600" y="2971800"/>
+            <a:ext cx="3273552" cy="548640"/>
           </a:xfrm>
           <a:prstGeom prst="rect">
             <a:avLst/>
@@ -8832,26 +8760,134 @@
               <a:buNone/>
             </a:pPr>
             <a:r>
-              <a:rPr lang="en-US" sz="1400" dirty="0">
+              <a:rPr lang="en-US" sz="2800" b="1" dirty="0">
                 <a:solidFill>
                   <a:schemeClr val="tx1"/>
                 </a:solidFill>
               </a:rPr>
-              <a:t>Self-play 對網路本身的直接提升較小，主要透過價值網路提升搜尋後的成績。</a:t>
+              <a:t>+0.14 → +0.06</a:t>
             </a:r>
-            <a:endParaRPr lang="en-US" sz="1400" dirty="0"/>
+            <a:endParaRPr lang="en-US" sz="2800" dirty="0"/>
           </a:p>
         </p:txBody>
       </p:sp>
       <p:sp>
         <p:nvSpPr>
-          <p:cNvPr id="11" name="footnote"/>
+          <p:cNvPr id="9" name="Text 6"/>
           <p:cNvSpPr txBox="1"/>
           <p:nvPr/>
         </p:nvSpPr>
         <p:spPr>
           <a:xfrm>
-            <a:off x="685800" y="5120640"/>
+            <a:off x="8229600" y="3657600"/>
+            <a:ext cx="3273552" cy="320040"/>
+          </a:xfrm>
+          <a:prstGeom prst="rect">
+            <a:avLst/>
+          </a:prstGeom>
+          <a:noFill/>
+          <a:ln/>
+        </p:spPr>
+        <p:txBody>
+          <a:bodyPr wrap="square" lIns="0" tIns="0" rIns="0" bIns="0" rtlCol="0" anchor="t"/>
+          <a:lstStyle/>
+          <a:p>
+            <a:pPr indent="0" marL="0">
+              <a:buNone/>
+            </a:pPr>
+            <a:r>
+              <a:rPr lang="en-US" sz="1500" b="1" dirty="0">
+                <a:solidFill>
+                  <a:schemeClr val="accent1"/>
+                </a:solidFill>
+              </a:rPr>
+              <a:t>Self-play</a:t>
+            </a:r>
+            <a:endParaRPr lang="en-US" sz="1500" dirty="0"/>
+          </a:p>
+        </p:txBody>
+      </p:sp>
+      <p:sp>
+        <p:nvSpPr>
+          <p:cNvPr id="10" name="Text 7"/>
+          <p:cNvSpPr txBox="1"/>
+          <p:nvPr/>
+        </p:nvSpPr>
+        <p:spPr>
+          <a:xfrm>
+            <a:off x="8229600" y="3977640"/>
+            <a:ext cx="3273552" cy="548640"/>
+          </a:xfrm>
+          <a:prstGeom prst="rect">
+            <a:avLst/>
+          </a:prstGeom>
+          <a:noFill/>
+          <a:ln/>
+        </p:spPr>
+        <p:txBody>
+          <a:bodyPr wrap="square" lIns="0" tIns="0" rIns="0" bIns="0" rtlCol="0" anchor="t"/>
+          <a:lstStyle/>
+          <a:p>
+            <a:pPr indent="0" marL="0">
+              <a:buNone/>
+            </a:pPr>
+            <a:r>
+              <a:rPr lang="en-US" sz="2800" b="1" dirty="0">
+                <a:solidFill>
+                  <a:schemeClr val="accent1"/>
+                </a:solidFill>
+              </a:rPr>
+              <a:t>+0.14 → +0.28</a:t>
+            </a:r>
+            <a:endParaRPr lang="en-US" sz="2800" dirty="0"/>
+          </a:p>
+        </p:txBody>
+      </p:sp>
+      <p:sp>
+        <p:nvSpPr>
+          <p:cNvPr id="11" name="Text 8"/>
+          <p:cNvSpPr txBox="1"/>
+          <p:nvPr/>
+        </p:nvSpPr>
+        <p:spPr>
+          <a:xfrm>
+            <a:off x="8229600" y="4663440"/>
+            <a:ext cx="3273552" cy="731520"/>
+          </a:xfrm>
+          <a:prstGeom prst="rect">
+            <a:avLst/>
+          </a:prstGeom>
+          <a:noFill/>
+          <a:ln/>
+        </p:spPr>
+        <p:txBody>
+          <a:bodyPr wrap="square" lIns="0" tIns="0" rIns="0" bIns="0" rtlCol="0" anchor="t"/>
+          <a:lstStyle/>
+          <a:p>
+            <a:pPr indent="0" marL="0">
+              <a:buNone/>
+            </a:pPr>
+            <a:r>
+              <a:rPr lang="en-US" sz="1300" dirty="0">
+                <a:solidFill>
+                  <a:schemeClr val="tx1"/>
+                </a:solidFill>
+              </a:rPr>
+              <a:t>Greedy 成功率提升相近（+0.16 / +0.17）；self-play 的優勢來自搜尋。</a:t>
+            </a:r>
+            <a:endParaRPr lang="en-US" sz="1300" dirty="0"/>
+          </a:p>
+        </p:txBody>
+      </p:sp>
+      <p:sp>
+        <p:nvSpPr>
+          <p:cNvPr id="12" name="footnote"/>
+          <p:cNvSpPr txBox="1"/>
+          <p:nvPr/>
+        </p:nvSpPr>
+        <p:spPr>
+          <a:xfrm>
+            <a:off x="685800" y="5577840"/>
             <a:ext cx="9875520" cy="274320"/>
           </a:xfrm>
           <a:prstGeom prst="rect">
@@ -8873,7 +8909,7 @@
                   <a:schemeClr val="tx2"/>
                 </a:solidFill>
               </a:rPr>
-              <a:t>100 局測試集，3 個 seed 平均。— 為報告未記錄（成功率與步數僅記錄於 PUCT16）。</a:t>
+              <a:t>100 局測試集，3 個 seed 平均（warm start 為 12 個實驗平均）。— 為報告未記錄；* 依成功率與成功局步數換算（失敗局以 30 步計）。</a:t>
             </a:r>
             <a:endParaRPr lang="en-US" sz="1100" dirty="0"/>
           </a:p>
@@ -9192,7 +9228,7 @@
         <p:spPr>
           <a:xfrm>
             <a:off x="6903720" y="5120640"/>
-            <a:ext cx="4599432" cy="548640"/>
+            <a:ext cx="4599432" cy="640080"/>
           </a:xfrm>
           <a:prstGeom prst="rect">
             <a:avLst/>
@@ -9213,7 +9249,7 @@
                   <a:schemeClr val="tx2"/>
                 </a:solidFill>
               </a:rPr>
-              <a:t>Warm start → Self-play（L3-goal）：PUCT16 +0.24，Greedy +0.13</a:t>
+              <a:t>成功率觀點（L3-goal）：搜尋多解出的局，teacher-only 由 14% 縮至 6%，self-play 由 14% 擴至 28%</a:t>
             </a:r>
             <a:endParaRPr lang="en-US" sz="1300" dirty="0"/>
           </a:p>
@@ -9379,18 +9415,18 @@
         </p:nvGraphicFramePr>
         <p:xfrm>
           <a:off x="685800" y="1645920"/>
-          <a:ext cx="7132320" cy="914400"/>
+          <a:ext cx="7589520" cy="914400"/>
         </p:xfrm>
         <a:graphic>
           <a:graphicData uri="http://schemas.openxmlformats.org/drawingml/2006/table">
             <a:tbl>
               <a:tblPr/>
               <a:tblGrid>
-                <a:gridCol w="2103120"/>
-                <a:gridCol w="1371600"/>
+                <a:gridCol w="1783080"/>
+                <a:gridCol w="1783080"/>
                 <a:gridCol w="1143000"/>
-                <a:gridCol w="1371600"/>
-                <a:gridCol w="1143000"/>
+                <a:gridCol w="1783080"/>
+                <a:gridCol w="1097280"/>
               </a:tblGrid>
               <a:tr h="457200">
                 <a:tc>
@@ -9402,14 +9438,14 @@
                         <a:buNone/>
                       </a:pPr>
                       <a:r>
-                        <a:rPr lang="en-US" sz="1200" b="1" dirty="0">
+                        <a:rPr lang="en-US" sz="1100" b="1" dirty="0">
                           <a:solidFill>
                             <a:schemeClr val="tx2"/>
                           </a:solidFill>
                         </a:rPr>
                         <a:t>方法</a:t>
                       </a:r>
-                      <a:endParaRPr lang="en-US" sz="1200" dirty="0"/>
+                      <a:endParaRPr lang="en-US" sz="1100" dirty="0"/>
                     </a:p>
                   </a:txBody>
                   <a:tcPr marL="91440" marR="91440" marT="45720" marB="45720" anchor="ctr">
@@ -9442,14 +9478,14 @@
                         <a:buNone/>
                       </a:pPr>
                       <a:r>
-                        <a:rPr lang="en-US" sz="1200" b="1" dirty="0">
+                        <a:rPr lang="en-US" sz="1100" b="1" dirty="0">
                           <a:solidFill>
                             <a:schemeClr val="tx2"/>
                           </a:solidFill>
                         </a:rPr>
                         <a:t>L1 PUCT16</a:t>
                       </a:r>
-                      <a:endParaRPr lang="en-US" sz="1200" dirty="0"/>
+                      <a:endParaRPr lang="en-US" sz="1100" dirty="0"/>
                     </a:p>
                   </a:txBody>
                   <a:tcPr marL="91440" marR="91440" marT="45720" marB="45720" anchor="ctr">
@@ -9482,14 +9518,14 @@
                         <a:buNone/>
                       </a:pPr>
                       <a:r>
-                        <a:rPr lang="en-US" sz="1200" b="1" dirty="0">
+                        <a:rPr lang="en-US" sz="1100" b="1" dirty="0">
                           <a:solidFill>
                             <a:schemeClr val="tx2"/>
                           </a:solidFill>
                         </a:rPr>
                         <a:t>L1 Greedy</a:t>
                       </a:r>
-                      <a:endParaRPr lang="en-US" sz="1200" dirty="0"/>
+                      <a:endParaRPr lang="en-US" sz="1100" dirty="0"/>
                     </a:p>
                   </a:txBody>
                   <a:tcPr marL="91440" marR="91440" marT="45720" marB="45720" anchor="ctr">
@@ -9522,14 +9558,14 @@
                         <a:buNone/>
                       </a:pPr>
                       <a:r>
-                        <a:rPr lang="en-US" sz="1200" b="1" dirty="0">
+                        <a:rPr lang="en-US" sz="1100" b="1" dirty="0">
                           <a:solidFill>
                             <a:schemeClr val="tx2"/>
                           </a:solidFill>
                         </a:rPr>
                         <a:t>L2 PUCT16</a:t>
                       </a:r>
-                      <a:endParaRPr lang="en-US" sz="1200" dirty="0"/>
+                      <a:endParaRPr lang="en-US" sz="1100" dirty="0"/>
                     </a:p>
                   </a:txBody>
                   <a:tcPr marL="91440" marR="91440" marT="45720" marB="45720" anchor="ctr">
@@ -9562,14 +9598,14 @@
                         <a:buNone/>
                       </a:pPr>
                       <a:r>
-                        <a:rPr lang="en-US" sz="1200" b="1" dirty="0">
+                        <a:rPr lang="en-US" sz="1100" b="1" dirty="0">
                           <a:solidFill>
                             <a:schemeClr val="tx2"/>
                           </a:solidFill>
                         </a:rPr>
                         <a:t>L2 Greedy</a:t>
                       </a:r>
-                      <a:endParaRPr lang="en-US" sz="1200" dirty="0"/>
+                      <a:endParaRPr lang="en-US" sz="1100" dirty="0"/>
                     </a:p>
                   </a:txBody>
                   <a:tcPr marL="91440" marR="91440" marT="45720" marB="45720" anchor="ctr">
@@ -9604,14 +9640,14 @@
                         <a:buNone/>
                       </a:pPr>
                       <a:r>
-                        <a:rPr lang="en-US" sz="1300" dirty="0">
+                        <a:rPr lang="en-US" sz="1200" dirty="0">
                           <a:solidFill>
                             <a:schemeClr val="tx2"/>
                           </a:solidFill>
                         </a:rPr>
                         <a:t>隨機 rollout 搜尋</a:t>
                       </a:r>
-                      <a:endParaRPr lang="en-US" sz="1300" dirty="0"/>
+                      <a:endParaRPr lang="en-US" sz="1200" dirty="0"/>
                     </a:p>
                   </a:txBody>
                   <a:tcPr marL="91440" marR="91440" marT="45720" marB="45720" anchor="ctr">
@@ -9644,14 +9680,14 @@
                         <a:buNone/>
                       </a:pPr>
                       <a:r>
-                        <a:rPr lang="en-US" sz="1300" dirty="0">
+                        <a:rPr lang="en-US" sz="1200" dirty="0">
                           <a:solidFill>
                             <a:schemeClr val="tx2"/>
                           </a:solidFill>
                         </a:rPr>
-                        <a:t>0.564 (0.70)</a:t>
-                      </a:r>
-                      <a:endParaRPr lang="en-US" sz="1300" dirty="0"/>
+                        <a:t>0.564 (0.69)</a:t>
+                      </a:r>
+                      <a:endParaRPr lang="en-US" sz="1200" dirty="0"/>
                     </a:p>
                   </a:txBody>
                   <a:tcPr marL="91440" marR="91440" marT="45720" marB="45720" anchor="ctr">
@@ -9684,14 +9720,14 @@
                         <a:buNone/>
                       </a:pPr>
                       <a:r>
-                        <a:rPr lang="en-US" sz="1300" dirty="0">
+                        <a:rPr lang="en-US" sz="1200" dirty="0">
                           <a:solidFill>
                             <a:schemeClr val="tx2"/>
                           </a:solidFill>
                         </a:rPr>
                         <a:t>—</a:t>
                       </a:r>
-                      <a:endParaRPr lang="en-US" sz="1300" dirty="0"/>
+                      <a:endParaRPr lang="en-US" sz="1200" dirty="0"/>
                     </a:p>
                   </a:txBody>
                   <a:tcPr marL="91440" marR="91440" marT="45720" marB="45720" anchor="ctr">
@@ -9724,14 +9760,14 @@
                         <a:buNone/>
                       </a:pPr>
                       <a:r>
-                        <a:rPr lang="en-US" sz="1300" dirty="0">
+                        <a:rPr lang="en-US" sz="1200" dirty="0">
                           <a:solidFill>
                             <a:schemeClr val="tx2"/>
                           </a:solidFill>
                         </a:rPr>
                         <a:t>0.156 (0.21)</a:t>
                       </a:r>
-                      <a:endParaRPr lang="en-US" sz="1300" dirty="0"/>
+                      <a:endParaRPr lang="en-US" sz="1200" dirty="0"/>
                     </a:p>
                   </a:txBody>
                   <a:tcPr marL="91440" marR="91440" marT="45720" marB="45720" anchor="ctr">
@@ -9764,14 +9800,14 @@
                         <a:buNone/>
                       </a:pPr>
                       <a:r>
-                        <a:rPr lang="en-US" sz="1300" dirty="0">
+                        <a:rPr lang="en-US" sz="1200" dirty="0">
                           <a:solidFill>
                             <a:schemeClr val="tx2"/>
                           </a:solidFill>
                         </a:rPr>
                         <a:t>—</a:t>
                       </a:r>
-                      <a:endParaRPr lang="en-US" sz="1300" dirty="0"/>
+                      <a:endParaRPr lang="en-US" sz="1200" dirty="0"/>
                     </a:p>
                   </a:txBody>
                   <a:tcPr marL="91440" marR="91440" marT="45720" marB="45720" anchor="ctr">
@@ -9806,14 +9842,14 @@
                         <a:buNone/>
                       </a:pPr>
                       <a:r>
-                        <a:rPr lang="en-US" sz="1300" dirty="0">
+                        <a:rPr lang="en-US" sz="1200" dirty="0">
                           <a:solidFill>
                             <a:schemeClr val="tx1"/>
                           </a:solidFill>
                         </a:rPr>
                         <a:t>原始 Laya</a:t>
                       </a:r>
-                      <a:endParaRPr lang="en-US" sz="1300" dirty="0"/>
+                      <a:endParaRPr lang="en-US" sz="1200" dirty="0"/>
                     </a:p>
                   </a:txBody>
                   <a:tcPr marL="91440" marR="91440" marT="45720" marB="45720" anchor="ctr">
@@ -9846,14 +9882,14 @@
                         <a:buNone/>
                       </a:pPr>
                       <a:r>
-                        <a:rPr lang="en-US" sz="1300" dirty="0">
+                        <a:rPr lang="en-US" sz="1200" dirty="0">
                           <a:solidFill>
                             <a:schemeClr val="tx1"/>
                           </a:solidFill>
                         </a:rPr>
-                        <a:t>0.446 (0.59)</a:t>
-                      </a:r>
-                      <a:endParaRPr lang="en-US" sz="1300" dirty="0"/>
+                        <a:t>0.447 (0.59)</a:t>
+                      </a:r>
+                      <a:endParaRPr lang="en-US" sz="1200" dirty="0"/>
                     </a:p>
                   </a:txBody>
                   <a:tcPr marL="91440" marR="91440" marT="45720" marB="45720" anchor="ctr">
@@ -9886,14 +9922,14 @@
                         <a:buNone/>
                       </a:pPr>
                       <a:r>
-                        <a:rPr lang="en-US" sz="1300" dirty="0">
+                        <a:rPr lang="en-US" sz="1200" dirty="0">
                           <a:solidFill>
                             <a:schemeClr val="tx1"/>
                           </a:solidFill>
                         </a:rPr>
-                        <a:t>0.254 (0.31)</a:t>
-                      </a:r>
-                      <a:endParaRPr lang="en-US" sz="1300" dirty="0"/>
+                        <a:t>0.253 (0.31)</a:t>
+                      </a:r>
+                      <a:endParaRPr lang="en-US" sz="1200" dirty="0"/>
                     </a:p>
                   </a:txBody>
                   <a:tcPr marL="91440" marR="91440" marT="45720" marB="45720" anchor="ctr">
@@ -9926,14 +9962,14 @@
                         <a:buNone/>
                       </a:pPr>
                       <a:r>
-                        <a:rPr lang="en-US" sz="1300" dirty="0">
+                        <a:rPr lang="en-US" sz="1200" dirty="0">
                           <a:solidFill>
                             <a:schemeClr val="tx1"/>
                           </a:solidFill>
                         </a:rPr>
                         <a:t>0.117 (0.18)</a:t>
                       </a:r>
-                      <a:endParaRPr lang="en-US" sz="1300" dirty="0"/>
+                      <a:endParaRPr lang="en-US" sz="1200" dirty="0"/>
                     </a:p>
                   </a:txBody>
                   <a:tcPr marL="91440" marR="91440" marT="45720" marB="45720" anchor="ctr">
@@ -9966,14 +10002,14 @@
                         <a:buNone/>
                       </a:pPr>
                       <a:r>
-                        <a:rPr lang="en-US" sz="1300" dirty="0">
+                        <a:rPr lang="en-US" sz="1200" dirty="0">
                           <a:solidFill>
                             <a:schemeClr val="tx1"/>
                           </a:solidFill>
                         </a:rPr>
                         <a:t>0.042 (0.06)</a:t>
                       </a:r>
-                      <a:endParaRPr lang="en-US" sz="1300" dirty="0"/>
+                      <a:endParaRPr lang="en-US" sz="1200" dirty="0"/>
                     </a:p>
                   </a:txBody>
                   <a:tcPr marL="91440" marR="91440" marT="45720" marB="45720" anchor="ctr">
@@ -10008,14 +10044,14 @@
                         <a:buNone/>
                       </a:pPr>
                       <a:r>
-                        <a:rPr lang="en-US" sz="1300" dirty="0">
+                        <a:rPr lang="en-US" sz="1200" dirty="0">
                           <a:solidFill>
                             <a:schemeClr val="tx1"/>
                           </a:solidFill>
                         </a:rPr>
                         <a:t>Warm start</a:t>
                       </a:r>
-                      <a:endParaRPr lang="en-US" sz="1300" dirty="0"/>
+                      <a:endParaRPr lang="en-US" sz="1200" dirty="0"/>
                     </a:p>
                   </a:txBody>
                   <a:tcPr marL="91440" marR="91440" marT="45720" marB="45720" anchor="ctr">
@@ -10048,14 +10084,14 @@
                         <a:buNone/>
                       </a:pPr>
                       <a:r>
-                        <a:rPr lang="en-US" sz="1300" dirty="0">
+                        <a:rPr lang="en-US" sz="1200" dirty="0">
                           <a:solidFill>
                             <a:schemeClr val="tx1"/>
                           </a:solidFill>
                         </a:rPr>
-                        <a:t>0.859</a:t>
-                      </a:r>
-                      <a:endParaRPr lang="en-US" sz="1300" dirty="0"/>
+                        <a:t>0.859 (0.99)</a:t>
+                      </a:r>
+                      <a:endParaRPr lang="en-US" sz="1200" dirty="0"/>
                     </a:p>
                   </a:txBody>
                   <a:tcPr marL="91440" marR="91440" marT="45720" marB="45720" anchor="ctr">
@@ -10088,14 +10124,14 @@
                         <a:buNone/>
                       </a:pPr>
                       <a:r>
-                        <a:rPr lang="en-US" sz="1300" dirty="0">
+                        <a:rPr lang="en-US" sz="1200" dirty="0">
                           <a:solidFill>
                             <a:schemeClr val="tx1"/>
                           </a:solidFill>
                         </a:rPr>
-                        <a:t>0.837</a:t>
-                      </a:r>
-                      <a:endParaRPr lang="en-US" sz="1300" dirty="0"/>
+                        <a:t>0.837 (0.97)</a:t>
+                      </a:r>
+                      <a:endParaRPr lang="en-US" sz="1200" dirty="0"/>
                     </a:p>
                   </a:txBody>
                   <a:tcPr marL="91440" marR="91440" marT="45720" marB="45720" anchor="ctr">
@@ -10128,14 +10164,14 @@
                         <a:buNone/>
                       </a:pPr>
                       <a:r>
-                        <a:rPr lang="en-US" sz="1300" dirty="0">
+                        <a:rPr lang="en-US" sz="1200" dirty="0">
                           <a:solidFill>
                             <a:schemeClr val="tx1"/>
                           </a:solidFill>
                         </a:rPr>
-                        <a:t>0.772</a:t>
-                      </a:r>
-                      <a:endParaRPr lang="en-US" sz="1300" dirty="0"/>
+                        <a:t>0.772 (0.98)</a:t>
+                      </a:r>
+                      <a:endParaRPr lang="en-US" sz="1200" dirty="0"/>
                     </a:p>
                   </a:txBody>
                   <a:tcPr marL="91440" marR="91440" marT="45720" marB="45720" anchor="ctr">
@@ -10168,14 +10204,14 @@
                         <a:buNone/>
                       </a:pPr>
                       <a:r>
-                        <a:rPr lang="en-US" sz="1300" dirty="0">
+                        <a:rPr lang="en-US" sz="1200" dirty="0">
                           <a:solidFill>
                             <a:schemeClr val="tx1"/>
                           </a:solidFill>
                         </a:rPr>
-                        <a:t>0.733</a:t>
-                      </a:r>
-                      <a:endParaRPr lang="en-US" sz="1300" dirty="0"/>
+                        <a:t>0.733 (0.93)</a:t>
+                      </a:r>
+                      <a:endParaRPr lang="en-US" sz="1200" dirty="0"/>
                     </a:p>
                   </a:txBody>
                   <a:tcPr marL="91440" marR="91440" marT="45720" marB="45720" anchor="ctr">
@@ -10210,14 +10246,14 @@
                         <a:buNone/>
                       </a:pPr>
                       <a:r>
-                        <a:rPr lang="en-US" sz="1300" dirty="0">
+                        <a:rPr lang="en-US" sz="1200" dirty="0">
                           <a:solidFill>
                             <a:schemeClr val="tx1"/>
                           </a:solidFill>
                         </a:rPr>
                         <a:t>Teacher-only</a:t>
                       </a:r>
-                      <a:endParaRPr lang="en-US" sz="1300" dirty="0"/>
+                      <a:endParaRPr lang="en-US" sz="1200" dirty="0"/>
                     </a:p>
                   </a:txBody>
                   <a:tcPr marL="91440" marR="91440" marT="45720" marB="45720" anchor="ctr">
@@ -10250,14 +10286,14 @@
                         <a:buNone/>
                       </a:pPr>
                       <a:r>
-                        <a:rPr lang="en-US" sz="1300" dirty="0">
+                        <a:rPr lang="en-US" sz="1200" dirty="0">
                           <a:solidFill>
                             <a:schemeClr val="tx1"/>
                           </a:solidFill>
                         </a:rPr>
-                        <a:t>0.857 ± 0.006</a:t>
-                      </a:r>
-                      <a:endParaRPr lang="en-US" sz="1300" dirty="0"/>
+                        <a:t>0.857 ± 0.006 (0.99)</a:t>
+                      </a:r>
+                      <a:endParaRPr lang="en-US" sz="1200" dirty="0"/>
                     </a:p>
                   </a:txBody>
                   <a:tcPr marL="91440" marR="91440" marT="45720" marB="45720" anchor="ctr">
@@ -10290,14 +10326,14 @@
                         <a:buNone/>
                       </a:pPr>
                       <a:r>
-                        <a:rPr lang="en-US" sz="1300" dirty="0">
+                        <a:rPr lang="en-US" sz="1200" dirty="0">
                           <a:solidFill>
                             <a:schemeClr val="tx1"/>
                           </a:solidFill>
                         </a:rPr>
-                        <a:t>0.837</a:t>
-                      </a:r>
-                      <a:endParaRPr lang="en-US" sz="1300" dirty="0"/>
+                        <a:t>0.837 (0.97)</a:t>
+                      </a:r>
+                      <a:endParaRPr lang="en-US" sz="1200" dirty="0"/>
                     </a:p>
                   </a:txBody>
                   <a:tcPr marL="91440" marR="91440" marT="45720" marB="45720" anchor="ctr">
@@ -10330,14 +10366,14 @@
                         <a:buNone/>
                       </a:pPr>
                       <a:r>
-                        <a:rPr lang="en-US" sz="1300" dirty="0">
+                        <a:rPr lang="en-US" sz="1200" dirty="0">
                           <a:solidFill>
                             <a:schemeClr val="tx1"/>
                           </a:solidFill>
                         </a:rPr>
-                        <a:t>0.776 ± 0.002</a:t>
-                      </a:r>
-                      <a:endParaRPr lang="en-US" sz="1300" dirty="0"/>
+                        <a:t>0.776 ± 0.002 (0.98)</a:t>
+                      </a:r>
+                      <a:endParaRPr lang="en-US" sz="1200" dirty="0"/>
                     </a:p>
                   </a:txBody>
                   <a:tcPr marL="91440" marR="91440" marT="45720" marB="45720" anchor="ctr">
@@ -10370,14 +10406,14 @@
                         <a:buNone/>
                       </a:pPr>
                       <a:r>
-                        <a:rPr lang="en-US" sz="1300" dirty="0">
+                        <a:rPr lang="en-US" sz="1200" dirty="0">
                           <a:solidFill>
                             <a:schemeClr val="tx1"/>
                           </a:solidFill>
                         </a:rPr>
-                        <a:t>0.753</a:t>
-                      </a:r>
-                      <a:endParaRPr lang="en-US" sz="1300" dirty="0"/>
+                        <a:t>0.753 (0.95)</a:t>
+                      </a:r>
+                      <a:endParaRPr lang="en-US" sz="1200" dirty="0"/>
                     </a:p>
                   </a:txBody>
                   <a:tcPr marL="91440" marR="91440" marT="45720" marB="45720" anchor="ctr">
@@ -10412,14 +10448,14 @@
                         <a:buNone/>
                       </a:pPr>
                       <a:r>
-                        <a:rPr lang="en-US" sz="1300" b="1" dirty="0">
+                        <a:rPr lang="en-US" sz="1200" b="1" dirty="0">
                           <a:solidFill>
                             <a:schemeClr val="accent1"/>
                           </a:solidFill>
                         </a:rPr>
                         <a:t>Self-play</a:t>
                       </a:r>
-                      <a:endParaRPr lang="en-US" sz="1300" dirty="0"/>
+                      <a:endParaRPr lang="en-US" sz="1200" dirty="0"/>
                     </a:p>
                   </a:txBody>
                   <a:tcPr marL="91440" marR="91440" marT="45720" marB="45720" anchor="ctr">
@@ -10452,14 +10488,14 @@
                         <a:buNone/>
                       </a:pPr>
                       <a:r>
-                        <a:rPr lang="en-US" sz="1300" b="1" dirty="0">
+                        <a:rPr lang="en-US" sz="1200" b="1" dirty="0">
                           <a:solidFill>
                             <a:schemeClr val="accent1"/>
                           </a:solidFill>
                         </a:rPr>
-                        <a:t>0.848 ± 0.014</a:t>
-                      </a:r>
-                      <a:endParaRPr lang="en-US" sz="1300" dirty="0"/>
+                        <a:t>0.848 ± 0.014 (0.98)</a:t>
+                      </a:r>
+                      <a:endParaRPr lang="en-US" sz="1200" dirty="0"/>
                     </a:p>
                   </a:txBody>
                   <a:tcPr marL="91440" marR="91440" marT="45720" marB="45720" anchor="ctr">
@@ -10492,14 +10528,14 @@
                         <a:buNone/>
                       </a:pPr>
                       <a:r>
-                        <a:rPr lang="en-US" sz="1300" b="1" dirty="0">
+                        <a:rPr lang="en-US" sz="1200" b="1" dirty="0">
                           <a:solidFill>
                             <a:schemeClr val="accent1"/>
                           </a:solidFill>
                         </a:rPr>
-                        <a:t>0.829</a:t>
-                      </a:r>
-                      <a:endParaRPr lang="en-US" sz="1300" dirty="0"/>
+                        <a:t>0.829 (0.96)</a:t>
+                      </a:r>
+                      <a:endParaRPr lang="en-US" sz="1200" dirty="0"/>
                     </a:p>
                   </a:txBody>
                   <a:tcPr marL="91440" marR="91440" marT="45720" marB="45720" anchor="ctr">
@@ -10532,14 +10568,14 @@
                         <a:buNone/>
                       </a:pPr>
                       <a:r>
-                        <a:rPr lang="en-US" sz="1300" b="1" dirty="0">
+                        <a:rPr lang="en-US" sz="1200" b="1" dirty="0">
                           <a:solidFill>
                             <a:schemeClr val="accent1"/>
                           </a:solidFill>
                         </a:rPr>
-                        <a:t>0.780 ± 0.004</a:t>
-                      </a:r>
-                      <a:endParaRPr lang="en-US" sz="1300" dirty="0"/>
+                        <a:t>0.780 ± 0.004 (0.99)</a:t>
+                      </a:r>
+                      <a:endParaRPr lang="en-US" sz="1200" dirty="0"/>
                     </a:p>
                   </a:txBody>
                   <a:tcPr marL="91440" marR="91440" marT="45720" marB="45720" anchor="ctr">
@@ -10572,14 +10608,14 @@
                         <a:buNone/>
                       </a:pPr>
                       <a:r>
-                        <a:rPr lang="en-US" sz="1300" b="1" dirty="0">
+                        <a:rPr lang="en-US" sz="1200" b="1" dirty="0">
                           <a:solidFill>
                             <a:schemeClr val="accent1"/>
                           </a:solidFill>
                         </a:rPr>
-                        <a:t>0.766</a:t>
-                      </a:r>
-                      <a:endParaRPr lang="en-US" sz="1300" dirty="0"/>
+                        <a:t>0.766 (0.97)</a:t>
+                      </a:r>
+                      <a:endParaRPr lang="en-US" sz="1200" dirty="0"/>
                     </a:p>
                   </a:txBody>
                   <a:tcPr marL="91440" marR="91440" marT="45720" marB="45720" anchor="ctr">
@@ -10614,14 +10650,14 @@
                         <a:buNone/>
                       </a:pPr>
                       <a:r>
-                        <a:rPr lang="en-US" sz="1300" dirty="0">
+                        <a:rPr lang="en-US" sz="1200" dirty="0">
                           <a:solidFill>
                             <a:schemeClr val="tx1"/>
                           </a:solidFill>
                         </a:rPr>
                         <a:t>成對差距（SP − TO）</a:t>
                       </a:r>
-                      <a:endParaRPr lang="en-US" sz="1300" dirty="0"/>
+                      <a:endParaRPr lang="en-US" sz="1200" dirty="0"/>
                     </a:p>
                   </a:txBody>
                   <a:tcPr marL="91440" marR="91440" marT="45720" marB="45720" anchor="ctr">
@@ -10654,14 +10690,14 @@
                         <a:buNone/>
                       </a:pPr>
                       <a:r>
-                        <a:rPr lang="en-US" sz="1300" dirty="0">
+                        <a:rPr lang="en-US" sz="1200" dirty="0">
                           <a:solidFill>
                             <a:schemeClr val="tx1"/>
                           </a:solidFill>
                         </a:rPr>
                         <a:t>−0.009 ± 0.008</a:t>
                       </a:r>
-                      <a:endParaRPr lang="en-US" sz="1300" dirty="0"/>
+                      <a:endParaRPr lang="en-US" sz="1200" dirty="0"/>
                     </a:p>
                   </a:txBody>
                   <a:tcPr marL="91440" marR="91440" marT="45720" marB="45720" anchor="ctr">
@@ -10693,7 +10729,7 @@
                       <a:pPr algn="ctr" indent="0" marL="0">
                         <a:buNone/>
                       </a:pPr>
-                      <a:endParaRPr lang="en-US" sz="1300" dirty="0"/>
+                      <a:endParaRPr lang="en-US" sz="1200" dirty="0"/>
                     </a:p>
                   </a:txBody>
                   <a:tcPr marL="91440" marR="91440" marT="45720" marB="45720" anchor="ctr">
@@ -10726,14 +10762,14 @@
                         <a:buNone/>
                       </a:pPr>
                       <a:r>
-                        <a:rPr lang="en-US" sz="1300" dirty="0">
+                        <a:rPr lang="en-US" sz="1200" dirty="0">
                           <a:solidFill>
                             <a:schemeClr val="tx1"/>
                           </a:solidFill>
                         </a:rPr>
                         <a:t>+0.004 ± 0.006</a:t>
                       </a:r>
-                      <a:endParaRPr lang="en-US" sz="1300" dirty="0"/>
+                      <a:endParaRPr lang="en-US" sz="1200" dirty="0"/>
                     </a:p>
                   </a:txBody>
                   <a:tcPr marL="91440" marR="91440" marT="45720" marB="45720" anchor="ctr">
@@ -10765,7 +10801,7 @@
                       <a:pPr algn="ctr" indent="0" marL="0">
                         <a:buNone/>
                       </a:pPr>
-                      <a:endParaRPr lang="en-US" sz="1300" dirty="0"/>
+                      <a:endParaRPr lang="en-US" sz="1200" dirty="0"/>
                     </a:p>
                   </a:txBody>
                   <a:tcPr marL="91440" marR="91440" marT="45720" marB="45720" anchor="ctr">
@@ -10800,14 +10836,14 @@
                         <a:buNone/>
                       </a:pPr>
                       <a:r>
-                        <a:rPr lang="en-US" sz="1300" dirty="0">
+                        <a:rPr lang="en-US" sz="1200" dirty="0">
                           <a:solidFill>
                             <a:schemeClr val="tx2"/>
                           </a:solidFill>
                         </a:rPr>
                         <a:t>理論最佳</a:t>
                       </a:r>
-                      <a:endParaRPr lang="en-US" sz="1300" dirty="0"/>
+                      <a:endParaRPr lang="en-US" sz="1200" dirty="0"/>
                     </a:p>
                   </a:txBody>
                   <a:tcPr marL="91440" marR="91440" marT="45720" marB="45720" anchor="ctr">
@@ -10840,14 +10876,14 @@
                         <a:buNone/>
                       </a:pPr>
                       <a:r>
-                        <a:rPr lang="en-US" sz="1300" dirty="0">
+                        <a:rPr lang="en-US" sz="1200" dirty="0">
                           <a:solidFill>
                             <a:schemeClr val="tx2"/>
                           </a:solidFill>
                         </a:rPr>
                         <a:t>0.864</a:t>
                       </a:r>
-                      <a:endParaRPr lang="en-US" sz="1300" dirty="0"/>
+                      <a:endParaRPr lang="en-US" sz="1200" dirty="0"/>
                     </a:p>
                   </a:txBody>
                   <a:tcPr marL="91440" marR="91440" marT="45720" marB="45720" anchor="ctr">
@@ -10879,7 +10915,7 @@
                       <a:pPr algn="ctr" indent="0" marL="0">
                         <a:buNone/>
                       </a:pPr>
-                      <a:endParaRPr lang="en-US" sz="1300" dirty="0"/>
+                      <a:endParaRPr lang="en-US" sz="1200" dirty="0"/>
                     </a:p>
                   </a:txBody>
                   <a:tcPr marL="91440" marR="91440" marT="45720" marB="45720" anchor="ctr">
@@ -10912,14 +10948,14 @@
                         <a:buNone/>
                       </a:pPr>
                       <a:r>
-                        <a:rPr lang="en-US" sz="1300" dirty="0">
+                        <a:rPr lang="en-US" sz="1200" dirty="0">
                           <a:solidFill>
                             <a:schemeClr val="tx2"/>
                           </a:solidFill>
                         </a:rPr>
                         <a:t>0.795</a:t>
                       </a:r>
-                      <a:endParaRPr lang="en-US" sz="1300" dirty="0"/>
+                      <a:endParaRPr lang="en-US" sz="1200" dirty="0"/>
                     </a:p>
                   </a:txBody>
                   <a:tcPr marL="91440" marR="91440" marT="45720" marB="45720" anchor="ctr">
@@ -10951,7 +10987,7 @@
                       <a:pPr algn="ctr" indent="0" marL="0">
                         <a:buNone/>
                       </a:pPr>
-                      <a:endParaRPr lang="en-US" sz="1300" dirty="0"/>
+                      <a:endParaRPr lang="en-US" sz="1200" dirty="0"/>
                     </a:p>
                   </a:txBody>
                   <a:tcPr marL="91440" marR="91440" marT="45720" marB="45720" anchor="ctr">
@@ -10988,8 +11024,8 @@
         </p:nvSpPr>
         <p:spPr>
           <a:xfrm>
-            <a:off x="8183880" y="1691640"/>
-            <a:ext cx="3319272" cy="365760"/>
+            <a:off x="8503920" y="1691640"/>
+            <a:ext cx="2999232" cy="365760"/>
           </a:xfrm>
           <a:prstGeom prst="rect">
             <a:avLst/>
@@ -11024,8 +11060,8 @@
         </p:nvSpPr>
         <p:spPr>
           <a:xfrm>
-            <a:off x="8183880" y="2103120"/>
-            <a:ext cx="3319272" cy="1371600"/>
+            <a:off x="8503920" y="2103120"/>
+            <a:ext cx="2999232" cy="1371600"/>
           </a:xfrm>
           <a:prstGeom prst="rect">
             <a:avLst/>
@@ -11082,8 +11118,8 @@
         </p:nvSpPr>
         <p:spPr>
           <a:xfrm>
-            <a:off x="8183880" y="3611880"/>
-            <a:ext cx="3319272" cy="365760"/>
+            <a:off x="8503920" y="3611880"/>
+            <a:ext cx="2999232" cy="365760"/>
           </a:xfrm>
           <a:prstGeom prst="rect">
             <a:avLst/>
@@ -11118,8 +11154,8 @@
         </p:nvSpPr>
         <p:spPr>
           <a:xfrm>
-            <a:off x="8183880" y="4023360"/>
-            <a:ext cx="3319272" cy="1371600"/>
+            <a:off x="8503920" y="4023360"/>
+            <a:ext cx="2999232" cy="1371600"/>
           </a:xfrm>
           <a:prstGeom prst="rect">
             <a:avLst/>
@@ -24896,7 +24932,7 @@
                             <a:schemeClr val="tx2"/>
                           </a:solidFill>
                         </a:rPr>
-                        <a:t>0.277 (0.32)</a:t>
+                        <a:t>0.278 (0.32)</a:t>
                       </a:r>
                       <a:endParaRPr lang="en-US" sz="1400" dirty="0"/>
                     </a:p>
@@ -25178,7 +25214,7 @@
                             <a:schemeClr val="tx1"/>
                           </a:solidFill>
                         </a:rPr>
-                        <a:t>0.140 (0.15)</a:t>
+                        <a:t>0.138 (0.15)</a:t>
                       </a:r>
                       <a:endParaRPr lang="en-US" sz="1400" dirty="0"/>
                     </a:p>
@@ -25300,7 +25336,7 @@
                             <a:schemeClr val="tx1"/>
                           </a:solidFill>
                         </a:rPr>
-                        <a:t>0.601</a:t>
+                        <a:t>0.600 (0.77)</a:t>
                       </a:r>
                       <a:endParaRPr lang="en-US" sz="1400" dirty="0"/>
                     </a:p>
@@ -25340,7 +25376,7 @@
                             <a:schemeClr val="tx1"/>
                           </a:solidFill>
                         </a:rPr>
-                        <a:t>0.501</a:t>
+                        <a:t>0.501 (0.65)</a:t>
                       </a:r>
                       <a:endParaRPr lang="en-US" sz="1400" dirty="0"/>
                     </a:p>
@@ -25380,7 +25416,7 @@
                             <a:schemeClr val="tx1"/>
                           </a:solidFill>
                         </a:rPr>
-                        <a:t>0.396</a:t>
+                        <a:t>0.396 (0.54)</a:t>
                       </a:r>
                       <a:endParaRPr lang="en-US" sz="1400" dirty="0"/>
                     </a:p>
@@ -25420,7 +25456,7 @@
                             <a:schemeClr val="tx1"/>
                           </a:solidFill>
                         </a:rPr>
-                        <a:t>0.303</a:t>
+                        <a:t>0.303 (0.42)</a:t>
                       </a:r>
                       <a:endParaRPr lang="en-US" sz="1400" dirty="0"/>
                     </a:p>
@@ -25582,7 +25618,7 @@
                             <a:schemeClr val="tx1"/>
                           </a:solidFill>
                         </a:rPr>
-                        <a:t>0.613</a:t>
+                        <a:t>0.613 (0.79)</a:t>
                       </a:r>
                       <a:endParaRPr lang="en-US" sz="1400" dirty="0"/>
                     </a:p>
@@ -25622,7 +25658,7 @@
                             <a:schemeClr val="tx1"/>
                           </a:solidFill>
                         </a:rPr>
-                        <a:t>0.579</a:t>
+                        <a:t>0.579 (0.74)</a:t>
                       </a:r>
                       <a:endParaRPr lang="en-US" sz="1400" dirty="0"/>
                     </a:p>
@@ -25662,7 +25698,7 @@
                             <a:schemeClr val="tx1"/>
                           </a:solidFill>
                         </a:rPr>
-                        <a:t>0.413</a:t>
+                        <a:t>0.413 (0.59)</a:t>
                       </a:r>
                       <a:endParaRPr lang="en-US" sz="1400" dirty="0"/>
                     </a:p>
@@ -25702,7 +25738,7 @@
                             <a:schemeClr val="tx1"/>
                           </a:solidFill>
                         </a:rPr>
-                        <a:t>0.371</a:t>
+                        <a:t>0.371 (0.53)</a:t>
                       </a:r>
                       <a:endParaRPr lang="en-US" sz="1400" dirty="0"/>
                     </a:p>
@@ -25742,7 +25778,7 @@
                             <a:schemeClr val="tx1"/>
                           </a:solidFill>
                         </a:rPr>
-                        <a:t>0.804</a:t>
+                        <a:t>0.804 (1.00)</a:t>
                       </a:r>
                       <a:endParaRPr lang="en-US" sz="1400" dirty="0"/>
                     </a:p>
@@ -25782,7 +25818,7 @@
                             <a:schemeClr val="tx1"/>
                           </a:solidFill>
                         </a:rPr>
-                        <a:t>0.804</a:t>
+                        <a:t>0.804 (1.00)</a:t>
                       </a:r>
                       <a:endParaRPr lang="en-US" sz="1400" dirty="0"/>
                     </a:p>
@@ -25864,7 +25900,7 @@
                             <a:schemeClr val="accent1"/>
                           </a:solidFill>
                         </a:rPr>
-                        <a:t>0.736</a:t>
+                        <a:t>0.736 (0.94)</a:t>
                       </a:r>
                       <a:endParaRPr lang="en-US" sz="1400" dirty="0"/>
                     </a:p>
@@ -25904,7 +25940,7 @@
                             <a:schemeClr val="accent1"/>
                           </a:solidFill>
                         </a:rPr>
-                        <a:t>0.590</a:t>
+                        <a:t>0.590 (0.76)</a:t>
                       </a:r>
                       <a:endParaRPr lang="en-US" sz="1400" dirty="0"/>
                     </a:p>
@@ -25944,7 +25980,7 @@
                             <a:schemeClr val="accent1"/>
                           </a:solidFill>
                         </a:rPr>
-                        <a:t>0.640</a:t>
+                        <a:t>0.640 (0.89)</a:t>
                       </a:r>
                       <a:endParaRPr lang="en-US" sz="1400" dirty="0"/>
                     </a:p>
@@ -25984,7 +26020,7 @@
                             <a:schemeClr val="accent1"/>
                           </a:solidFill>
                         </a:rPr>
-                        <a:t>0.428</a:t>
+                        <a:t>0.428 (0.61)</a:t>
                       </a:r>
                       <a:endParaRPr lang="en-US" sz="1400" dirty="0"/>
                     </a:p>
@@ -26024,7 +26060,7 @@
                             <a:schemeClr val="accent1"/>
                           </a:solidFill>
                         </a:rPr>
-                        <a:t>0.804</a:t>
+                        <a:t>0.804 (1.00)</a:t>
                       </a:r>
                       <a:endParaRPr lang="en-US" sz="1400" dirty="0"/>
                     </a:p>
@@ -26064,7 +26100,7 @@
                             <a:schemeClr val="accent1"/>
                           </a:solidFill>
                         </a:rPr>
-                        <a:t>0.804</a:t>
+                        <a:t>0.804 (1.00)</a:t>
                       </a:r>
                       <a:endParaRPr lang="en-US" sz="1400" dirty="0"/>
                     </a:p>

</xml_diff>